<commit_message>
Update PowerPoint for song #195 in FUBC - Українські
</commit_message>
<xml_diff>
--- a/fubc-ua/195-Радійте, співайте і славте (Пісні Спасенних №193).pptx
+++ b/fubc-ua/195-Радійте, співайте і славте (Пісні Спасенних №193).pptx
@@ -1713,23 +1713,6 @@
             </a:r>
             <a:endParaRPr lang="en-US" sz="5200" dirty="0"/>
           </a:p>
-          <a:p>
-            <a:pPr algn="ctr" indent="0" marL="0">
-              <a:buNone/>
-            </a:pPr>
-            <a:r>
-              <a:rPr lang="en-US" sz="5200" b="1" dirty="0">
-                <a:solidFill>
-                  <a:srgbClr val="FFFFFF"/>
-                </a:solidFill>
-                <a:latin typeface="Arial" pitchFamily="34" charset="0"/>
-                <a:ea typeface="Arial" pitchFamily="34" charset="-122"/>
-                <a:cs typeface="Arial" pitchFamily="34" charset="-120"/>
-              </a:rPr>
-              <a:t>(Пісні Спасенних №193)</a:t>
-            </a:r>
-            <a:endParaRPr lang="en-US" sz="5200" dirty="0"/>
-          </a:p>
         </p:txBody>
       </p:sp>
     </p:spTree>
@@ -1968,7 +1951,7 @@
                 <a:ea typeface="Arial" pitchFamily="34" charset="-122"/>
                 <a:cs typeface="Arial" pitchFamily="34" charset="-120"/>
               </a:rPr>
-              <a:t>співайте і славте Христа (Христа)!</a:t>
+              <a:t>співайте і славте Христа!</a:t>
             </a:r>
             <a:endParaRPr lang="en-US" sz="5200" dirty="0"/>
           </a:p>
@@ -2212,7 +2195,7 @@
                 <a:ea typeface="Arial" pitchFamily="34" charset="-122"/>
                 <a:cs typeface="Arial" pitchFamily="34" charset="-120"/>
               </a:rPr>
-              <a:t>співайте і славте Христа (Христа)!</a:t>
+              <a:t>співайте і славте Христа!</a:t>
             </a:r>
             <a:endParaRPr lang="en-US" sz="5200" dirty="0"/>
           </a:p>
@@ -2456,7 +2439,7 @@
                 <a:ea typeface="Arial" pitchFamily="34" charset="-122"/>
                 <a:cs typeface="Arial" pitchFamily="34" charset="-120"/>
               </a:rPr>
-              <a:t>співайте і славте Христа (Христа)!</a:t>
+              <a:t>співайте і славте Христа!</a:t>
             </a:r>
             <a:endParaRPr lang="en-US" sz="5200" dirty="0"/>
           </a:p>
@@ -2700,7 +2683,7 @@
                 <a:ea typeface="Arial" pitchFamily="34" charset="-122"/>
                 <a:cs typeface="Arial" pitchFamily="34" charset="-120"/>
               </a:rPr>
-              <a:t>співайте і славте Христа (Христа)!</a:t>
+              <a:t>співайте і славте Христа!</a:t>
             </a:r>
             <a:endParaRPr lang="en-US" sz="5200" dirty="0"/>
           </a:p>

</xml_diff>